<commit_message>
Deck: surface the OpenAI API credit issue honestly
- Exec-summary scope banner now names it: LLM scaling paused on an OpenAI
  credit issue being resolved; pipeline runs, only the paid step is gated
  (~$0.39 spent, 37 of 126 scraped events scored)
- Verdict slide 'Thin data' card reframed to 'Thin data + API gate'
</commit_message>
<xml_diff>
--- a/reports/week6_llm_ma_prediction_presentation.pptx
+++ b/reports/week6_llm_ma_prediction_presentation.pptx
@@ -7781,7 +7781,7 @@
                 </a:solidFill>
                 <a:latin typeface="Calibri"/>
               </a:rPr>
-              <a:t>Thin, noisy data</a:t>
+              <a:t>Thin data + API gate</a:t>
             </a:r>
           </a:p>
         </p:txBody>
@@ -7864,7 +7864,7 @@
                 </a:solidFill>
                 <a:latin typeface="Calibri"/>
               </a:rPr>
-              <a:t>Free headlines are sparse; small test</a:t>
+              <a:t>Only 37 events LLM-scored — an OpenAI</a:t>
             </a:r>
           </a:p>
           <a:p>
@@ -7880,7 +7880,7 @@
                 </a:solidFill>
                 <a:latin typeface="Calibri"/>
               </a:rPr>
-              <a:t>sets swing AUC by ±0.05+.</a:t>
+              <a:t>credit issue paused scaling (resolving now);</a:t>
             </a:r>
           </a:p>
           <a:p>
@@ -7896,7 +7896,7 @@
                 </a:solidFill>
                 <a:latin typeface="Calibri"/>
               </a:rPr>
-              <a:t>Fix: scale the resumable scrape, add</a:t>
+              <a:t>small test sets swing AUC ±0.05+.</a:t>
             </a:r>
           </a:p>
           <a:p>
@@ -7912,7 +7912,23 @@
                 </a:solidFill>
                 <a:latin typeface="Calibri"/>
               </a:rPr>
-              <a:t>article bodies, walk-forward validation.</a:t>
+              <a:t>Fix: fund credits (full run ≈ a few $),</a:t>
+            </a:r>
+          </a:p>
+          <a:p>
+            <a:pPr algn="l">
+              <a:lnSpc>
+                <a:spcPct val="100000"/>
+              </a:lnSpc>
+            </a:pPr>
+            <a:r>
+              <a:rPr sz="1250" b="0">
+                <a:solidFill>
+                  <a:srgbClr val="1A3A5C"/>
+                </a:solidFill>
+                <a:latin typeface="Calibri"/>
+              </a:rPr>
+              <a:t>scale scrape, add article bodies.</a:t>
             </a:r>
           </a:p>
         </p:txBody>
@@ -10607,8 +10623,8 @@
         </p:nvSpPr>
         <p:spPr>
           <a:xfrm>
-            <a:off x="365760" y="2578608"/>
-            <a:ext cx="11091672" cy="274320"/>
+            <a:off x="365760" y="2505456"/>
+            <a:ext cx="11091672" cy="438912"/>
           </a:xfrm>
           <a:prstGeom prst="rect">
             <a:avLst/>
@@ -10651,8 +10667,8 @@
         </p:nvSpPr>
         <p:spPr>
           <a:xfrm>
-            <a:off x="457200" y="2560320"/>
-            <a:ext cx="10972800" cy="310896"/>
+            <a:off x="457200" y="2505456"/>
+            <a:ext cx="10972800" cy="438912"/>
           </a:xfrm>
           <a:prstGeom prst="rect">
             <a:avLst/>
@@ -10667,17 +10683,33 @@
           <a:p>
             <a:pPr algn="l">
               <a:lnSpc>
-                <a:spcPct val="100000"/>
-              </a:lnSpc>
-            </a:pPr>
-            <a:r>
-              <a:rPr sz="1150" b="1">
+                <a:spcPct val="105000"/>
+              </a:lnSpc>
+            </a:pPr>
+            <a:r>
+              <a:rPr sz="1050" b="1">
                 <a:solidFill>
                   <a:srgbClr val="1A3A5C"/>
                 </a:solidFill>
                 <a:latin typeface="Calibri"/>
               </a:rPr>
-              <a:t>Honest scope: 65 modeling windows from 37 LLM-scored events (13 in the held-out test split). LLM coverage was budget-limited (~$0.40 spent). Small sample — every AUC carries a bootstrap 95% CI; read these as DIRECTIONAL, not settled.</a:t>
+              <a:t>Honest scope: 65 windows from 37 LLM-scored events (13 in test). Small sample — read every AUC as DIRECTIONAL (bootstrap 95% CIs), not settled.</a:t>
+            </a:r>
+          </a:p>
+          <a:p>
+            <a:pPr algn="l">
+              <a:lnSpc>
+                <a:spcPct val="105000"/>
+              </a:lnSpc>
+            </a:pPr>
+            <a:r>
+              <a:rPr sz="1050" b="1">
+                <a:solidFill>
+                  <a:srgbClr val="1A3A5C"/>
+                </a:solidFill>
+                <a:latin typeface="Calibri"/>
+              </a:rPr>
+              <a:t>⚠  LLM scaling currently paused on an OpenAI API credit issue we're resolving — the pipeline is built and runs; only the paid LLM step is gated (~$0.39 spent, 37 of 126 scraped events scored).</a:t>
             </a:r>
           </a:p>
         </p:txBody>

</xml_diff>

<commit_message>
Deck: reconcile the 71% acquirer-recall number on the memorization-probe slide
Add an 'Is the 71% a memorization problem?' panel that reads the four
probe numbers together — entity recall (71%) is real but not time-
localized (yes/no at chance), and pre- vs post-cutoff shows no gap, so
memory adds no prediction edge. Fix the bottom callout, which previously
overclaimed 'no recall' (contradicted by the 71%).
</commit_message>
<xml_diff>
--- a/reports/week6_llm_ma_prediction_presentation.pptx
+++ b/reports/week6_llm_ma_prediction_presentation.pptx
@@ -4252,6 +4252,247 @@
         </p:nvSpPr>
         <p:spPr>
           <a:xfrm>
+            <a:off x="6035040" y="3977639"/>
+            <a:ext cx="5605272" cy="384048"/>
+          </a:xfrm>
+          <a:prstGeom prst="rect">
+            <a:avLst/>
+          </a:prstGeom>
+          <a:solidFill>
+            <a:srgbClr val="2E6DB4"/>
+          </a:solidFill>
+          <a:ln>
+            <a:noFill/>
+          </a:ln>
+          <a:effectLst/>
+        </p:spPr>
+        <p:style>
+          <a:lnRef idx="1">
+            <a:schemeClr val="accent1"/>
+          </a:lnRef>
+          <a:fillRef idx="3">
+            <a:schemeClr val="accent1"/>
+          </a:fillRef>
+          <a:effectRef idx="2">
+            <a:schemeClr val="accent1"/>
+          </a:effectRef>
+          <a:fontRef idx="minor">
+            <a:schemeClr val="lt1"/>
+          </a:fontRef>
+        </p:style>
+        <p:txBody>
+          <a:bodyPr rtlCol="0" anchor="ctr"/>
+          <a:lstStyle/>
+          <a:p>
+            <a:pPr algn="ctr"/>
+          </a:p>
+        </p:txBody>
+      </p:sp>
+      <p:sp>
+        <p:nvSpPr>
+          <p:cNvPr id="21" name="TextBox 20"/>
+          <p:cNvSpPr txBox="1"/>
+          <p:nvPr/>
+        </p:nvSpPr>
+        <p:spPr>
+          <a:xfrm>
+            <a:off x="6035040" y="3986783"/>
+            <a:ext cx="5605272" cy="365760"/>
+          </a:xfrm>
+          <a:prstGeom prst="rect">
+            <a:avLst/>
+          </a:prstGeom>
+          <a:noFill/>
+        </p:spPr>
+        <p:txBody>
+          <a:bodyPr wrap="square" anchor="t" lIns="45720" rIns="45720" tIns="22860" bIns="22860">
+            <a:spAutoFit/>
+          </a:bodyPr>
+          <a:lstStyle/>
+          <a:p>
+            <a:pPr algn="ctr">
+              <a:lnSpc>
+                <a:spcPct val="100000"/>
+              </a:lnSpc>
+            </a:pPr>
+            <a:r>
+              <a:rPr sz="1500" b="1">
+                <a:solidFill>
+                  <a:srgbClr val="FFFFFF"/>
+                </a:solidFill>
+                <a:latin typeface="Calibri"/>
+              </a:rPr>
+              <a:t>Is the 71% a memorization problem?</a:t>
+            </a:r>
+          </a:p>
+        </p:txBody>
+      </p:sp>
+      <p:sp>
+        <p:nvSpPr>
+          <p:cNvPr id="22" name="Rectangle 21"/>
+          <p:cNvSpPr/>
+          <p:nvPr/>
+        </p:nvSpPr>
+        <p:spPr>
+          <a:xfrm>
+            <a:off x="6035040" y="4361687"/>
+            <a:ext cx="5605272" cy="1353312"/>
+          </a:xfrm>
+          <a:prstGeom prst="rect">
+            <a:avLst/>
+          </a:prstGeom>
+          <a:solidFill>
+            <a:srgbClr val="F0F0F0"/>
+          </a:solidFill>
+          <a:ln>
+            <a:noFill/>
+          </a:ln>
+          <a:effectLst/>
+        </p:spPr>
+        <p:style>
+          <a:lnRef idx="1">
+            <a:schemeClr val="accent1"/>
+          </a:lnRef>
+          <a:fillRef idx="3">
+            <a:schemeClr val="accent1"/>
+          </a:fillRef>
+          <a:effectRef idx="2">
+            <a:schemeClr val="accent1"/>
+          </a:effectRef>
+          <a:fontRef idx="minor">
+            <a:schemeClr val="lt1"/>
+          </a:fontRef>
+        </p:style>
+        <p:txBody>
+          <a:bodyPr rtlCol="0" anchor="ctr"/>
+          <a:lstStyle/>
+          <a:p>
+            <a:pPr algn="ctr"/>
+          </a:p>
+        </p:txBody>
+      </p:sp>
+      <p:sp>
+        <p:nvSpPr>
+          <p:cNvPr id="23" name="TextBox 22"/>
+          <p:cNvSpPr txBox="1"/>
+          <p:nvPr/>
+        </p:nvSpPr>
+        <p:spPr>
+          <a:xfrm>
+            <a:off x="6108192" y="4453127"/>
+            <a:ext cx="5458968" cy="1170432"/>
+          </a:xfrm>
+          <a:prstGeom prst="rect">
+            <a:avLst/>
+          </a:prstGeom>
+          <a:noFill/>
+        </p:spPr>
+        <p:txBody>
+          <a:bodyPr wrap="square" anchor="t" lIns="45720" rIns="45720" tIns="22860" bIns="22860">
+            <a:spAutoFit/>
+          </a:bodyPr>
+          <a:lstStyle/>
+          <a:p>
+            <a:pPr algn="l">
+              <a:lnSpc>
+                <a:spcPct val="100000"/>
+              </a:lnSpc>
+            </a:pPr>
+            <a:r>
+              <a:rPr sz="1150" b="1">
+                <a:solidFill>
+                  <a:srgbClr val="1A3A5C"/>
+                </a:solidFill>
+                <a:latin typeface="Calibri"/>
+              </a:rPr>
+              <a:t>No — real memory, but not time-localized:</a:t>
+            </a:r>
+          </a:p>
+          <a:p>
+            <a:pPr algn="l">
+              <a:lnSpc>
+                <a:spcPct val="100000"/>
+              </a:lnSpc>
+            </a:pPr>
+            <a:r>
+              <a:rPr sz="1050" b="1">
+                <a:solidFill>
+                  <a:srgbClr val="1A3A5C"/>
+                </a:solidFill>
+                <a:latin typeface="Calibri"/>
+              </a:rPr>
+              <a:t>71% acquirer recall</a:t>
+            </a:r>
+            <a:r>
+              <a:rPr sz="1050" b="0">
+                <a:solidFill>
+                  <a:srgbClr val="1A3A5C"/>
+                </a:solidFill>
+                <a:latin typeface="Calibri"/>
+              </a:rPr>
+              <a:t>  = entity memory, only on the 17 windows it self-flags (knows who bought whom).</a:t>
+            </a:r>
+          </a:p>
+          <a:p>
+            <a:pPr algn="l">
+              <a:lnSpc>
+                <a:spcPct val="100000"/>
+              </a:lnSpc>
+            </a:pPr>
+            <a:r>
+              <a:rPr sz="1050" b="1">
+                <a:solidFill>
+                  <a:srgbClr val="1A3A5C"/>
+                </a:solidFill>
+                <a:latin typeface="Calibri"/>
+              </a:rPr>
+              <a:t>52% yes/no ≈ chance</a:t>
+            </a:r>
+            <a:r>
+              <a:rPr sz="1050" b="0">
+                <a:solidFill>
+                  <a:srgbClr val="1A3A5C"/>
+                </a:solidFill>
+                <a:latin typeface="Calibri"/>
+              </a:rPr>
+              <a:t>  = but it can't place a deal in time (a fact has no timeline).</a:t>
+            </a:r>
+          </a:p>
+          <a:p>
+            <a:pPr algn="l">
+              <a:lnSpc>
+                <a:spcPct val="100000"/>
+              </a:lnSpc>
+            </a:pPr>
+            <a:r>
+              <a:rPr sz="1050" b="1">
+                <a:solidFill>
+                  <a:srgbClr val="1A3A5C"/>
+                </a:solidFill>
+                <a:latin typeface="Calibri"/>
+              </a:rPr>
+              <a:t>52% pre ≈ 50% post-cutoff</a:t>
+            </a:r>
+            <a:r>
+              <a:rPr sz="1050" b="0">
+                <a:solidFill>
+                  <a:srgbClr val="1A3A5C"/>
+                </a:solidFill>
+                <a:latin typeface="Calibri"/>
+              </a:rPr>
+              <a:t>  = deals it could have memorized score no higher than ones it never saw ⇒ no edge.</a:t>
+            </a:r>
+          </a:p>
+        </p:txBody>
+      </p:sp>
+      <p:sp>
+        <p:nvSpPr>
+          <p:cNvPr id="24" name="Rectangle 23"/>
+          <p:cNvSpPr/>
+          <p:nvPr/>
+        </p:nvSpPr>
+        <p:spPr>
+          <a:xfrm>
             <a:off x="365760" y="5806440"/>
             <a:ext cx="11457432" cy="685800"/>
           </a:xfrm>
@@ -4290,7 +4531,7 @@
       </p:sp>
       <p:sp>
         <p:nvSpPr>
-          <p:cNvPr id="21" name="TextBox 20"/>
+          <p:cNvPr id="25" name="TextBox 24"/>
           <p:cNvSpPr txBox="1"/>
           <p:nvPr/>
         </p:nvSpPr>
@@ -4322,14 +4563,14 @@
                 </a:solidFill>
                 <a:latin typeface="Calibri"/>
               </a:rPr>
-              <a:t>Probe accuracy 52% ≈ chance — no strong evidence the model recalls these specific deals.</a:t>
-            </a:r>
-          </a:p>
-        </p:txBody>
-      </p:sp>
-      <p:sp>
-        <p:nvSpPr>
-          <p:cNvPr id="22" name="Rectangle 21"/>
+              <a:t>Memorization is real but NOT time-localized: 71% acquirer recall, yet the yes/no probe is at chance and pre- ≈ post-cutoff — so it does not inflate the results.</a:t>
+            </a:r>
+          </a:p>
+        </p:txBody>
+      </p:sp>
+      <p:sp>
+        <p:nvSpPr>
+          <p:cNvPr id="26" name="Rectangle 25"/>
           <p:cNvSpPr/>
           <p:nvPr/>
         </p:nvSpPr>
@@ -4373,7 +4614,7 @@
       </p:sp>
       <p:sp>
         <p:nvSpPr>
-          <p:cNvPr id="23" name="TextBox 22"/>
+          <p:cNvPr id="27" name="TextBox 26"/>
           <p:cNvSpPr txBox="1"/>
           <p:nvPr/>
         </p:nvSpPr>

</xml_diff>